<commit_message>
Align recommendation interests and use English submission materials
</commit_message>
<xml_diff>
--- a/share/site/assets/RoamWise_MS2.pptx
+++ b/share/site/assets/RoamWise_MS2.pptx
@@ -412,703 +412,703 @@
 </file>
 
 <file path=ppt/notesSlides/notesSlide1.xml><?xml version="1.0" encoding="utf-8"?>
-<p:notes xmlns:p="http://schemas.openxmlformats.org/presentationml/2006/main">
-  <p:cSld>
-    <p:spTree>
-      <p:nvGrpSpPr>
-        <p:cNvPr id="1" name=""/>
-        <p:cNvGrpSpPr/>
-        <p:nvPr/>
-      </p:nvGrpSpPr>
-      <p:grpSpPr>
-        <a:xfrm xmlns:a="http://schemas.openxmlformats.org/drawingml/2006/main"/>
-      </p:grpSpPr>
-      <p:sp>
-        <p:nvSpPr>
-          <p:cNvPr id="2" name="Slide Image Placeholder 1"/>
-          <p:cNvSpPr>
-            <a:spLocks xmlns:a="http://schemas.openxmlformats.org/drawingml/2006/main" noGrp="1"/>
-          </p:cNvSpPr>
-          <p:nvPr>
-            <p:ph type="sldImg" idx="0"/>
-          </p:nvPr>
-        </p:nvSpPr>
-        <p:spPr/>
-      </p:sp>
-      <p:sp>
-        <p:nvSpPr>
-          <p:cNvPr id="3" name="Notes Placeholder 2"/>
-          <p:cNvSpPr>
-            <a:spLocks xmlns:a="http://schemas.openxmlformats.org/drawingml/2006/main" noGrp="1"/>
-          </p:cNvSpPr>
-          <p:nvPr>
-            <p:ph type="body" idx="1"/>
-          </p:nvPr>
-        </p:nvSpPr>
-        <p:spPr/>
-        <p:txBody>
-          <a:bodyPr xmlns:a="http://schemas.openxmlformats.org/drawingml/2006/main"/>
-          <a:lstStyle xmlns:a="http://schemas.openxmlformats.org/drawingml/2006/main"/>
-          <a:p xmlns:a="http://schemas.openxmlformats.org/drawingml/2006/main">
-            <a:r>
-              <a:t>约45秒。介绍 RoamWise 是 Boston 周边地点检索原型；这一阶段展示可复现的检索流程。资料来自真实历史地点和评论。团队需按实际情况介绍成员及分工。</a:t>
-            </a:r>
-          </a:p>
-        </p:txBody>
-      </p:sp>
-      <p:sp>
-        <p:nvSpPr>
-          <p:cNvPr id="4" name="Slide Number Placeholder 3"/>
-          <p:cNvSpPr>
-            <a:spLocks xmlns:a="http://schemas.openxmlformats.org/drawingml/2006/main" noGrp="1"/>
-          </p:cNvSpPr>
-          <p:nvPr>
-            <p:ph type="sldNum" idx="5"/>
-          </p:nvPr>
-        </p:nvSpPr>
-        <p:spPr/>
-        <p:txBody>
-          <a:bodyPr xmlns:a="http://schemas.openxmlformats.org/drawingml/2006/main"/>
-          <a:lstStyle xmlns:a="http://schemas.openxmlformats.org/drawingml/2006/main"/>
-          <a:p xmlns:a="http://schemas.openxmlformats.org/drawingml/2006/main"/>
-        </p:txBody>
-      </p:sp>
-    </p:spTree>
-  </p:cSld>
-  <p:clrMapOvr>
-    <a:masterClrMapping xmlns:a="http://schemas.openxmlformats.org/drawingml/2006/main"/>
-  </p:clrMapOvr>
-</p:notes>
+<ns0:notes xmlns:ns0="http://schemas.openxmlformats.org/presentationml/2006/main" xmlns:ns1="http://schemas.openxmlformats.org/drawingml/2006/main">
+  <ns0:cSld>
+    <ns0:spTree>
+      <ns0:nvGrpSpPr>
+        <ns0:cNvPr id="1" name=""/>
+        <ns0:cNvGrpSpPr/>
+        <ns0:nvPr/>
+      </ns0:nvGrpSpPr>
+      <ns0:grpSpPr>
+        <ns1:xfrm/>
+      </ns0:grpSpPr>
+      <ns0:sp>
+        <ns0:nvSpPr>
+          <ns0:cNvPr id="2" name="Slide Image Placeholder 1"/>
+          <ns0:cNvSpPr>
+            <ns1:spLocks noGrp="1"/>
+          </ns0:cNvSpPr>
+          <ns0:nvPr>
+            <ns0:ph type="sldImg" idx="0"/>
+          </ns0:nvPr>
+        </ns0:nvSpPr>
+        <ns0:spPr/>
+      </ns0:sp>
+      <ns0:sp>
+        <ns0:nvSpPr>
+          <ns0:cNvPr id="3" name="Notes Placeholder 2"/>
+          <ns0:cNvSpPr>
+            <ns1:spLocks noGrp="1"/>
+          </ns0:cNvSpPr>
+          <ns0:nvPr>
+            <ns0:ph type="body" idx="1"/>
+          </ns0:nvPr>
+        </ns0:nvSpPr>
+        <ns0:spPr/>
+        <ns0:txBody>
+          <ns1:bodyPr/>
+          <ns1:lstStyle/>
+          <ns1:p>
+            <ns1:r>
+              <ns1:t>About 45 seconds. This deck records the earlier retrieval-only release. Use docs/PRESENTATION_NOTES.md for the current LLM/RAG demonstration. Introduce the Greater Boston place-search prototype and its historical sources. State the team members and their actual contributions.</ns1:t>
+            </ns1:r>
+          </ns1:p>
+        </ns0:txBody>
+      </ns0:sp>
+      <ns0:sp>
+        <ns0:nvSpPr>
+          <ns0:cNvPr id="4" name="Slide Number Placeholder 3"/>
+          <ns0:cNvSpPr>
+            <ns1:spLocks noGrp="1"/>
+          </ns0:cNvSpPr>
+          <ns0:nvPr>
+            <ns0:ph type="sldNum" idx="5"/>
+          </ns0:nvPr>
+        </ns0:nvSpPr>
+        <ns0:spPr/>
+        <ns0:txBody>
+          <ns1:bodyPr/>
+          <ns1:lstStyle/>
+          <ns1:p/>
+        </ns0:txBody>
+      </ns0:sp>
+    </ns0:spTree>
+  </ns0:cSld>
+  <ns0:clrMapOvr>
+    <ns1:masterClrMapping/>
+  </ns0:clrMapOvr>
+</ns0:notes>
 </file>
 
 <file path=ppt/notesSlides/notesSlide10.xml><?xml version="1.0" encoding="utf-8"?>
-<p:notes xmlns:p="http://schemas.openxmlformats.org/presentationml/2006/main">
-  <p:cSld>
-    <p:spTree>
-      <p:nvGrpSpPr>
-        <p:cNvPr id="1" name=""/>
-        <p:cNvGrpSpPr/>
-        <p:nvPr/>
-      </p:nvGrpSpPr>
-      <p:grpSpPr>
-        <a:xfrm xmlns:a="http://schemas.openxmlformats.org/drawingml/2006/main"/>
-      </p:grpSpPr>
-      <p:sp>
-        <p:nvSpPr>
-          <p:cNvPr id="2" name="Slide Image Placeholder 1"/>
-          <p:cNvSpPr>
-            <a:spLocks xmlns:a="http://schemas.openxmlformats.org/drawingml/2006/main" noGrp="1"/>
-          </p:cNvSpPr>
-          <p:nvPr>
-            <p:ph type="sldImg" idx="0"/>
-          </p:nvPr>
-        </p:nvSpPr>
-        <p:spPr/>
-      </p:sp>
-      <p:sp>
-        <p:nvSpPr>
-          <p:cNvPr id="3" name="Notes Placeholder 2"/>
-          <p:cNvSpPr>
-            <a:spLocks xmlns:a="http://schemas.openxmlformats.org/drawingml/2006/main" noGrp="1"/>
-          </p:cNvSpPr>
-          <p:nvPr>
-            <p:ph type="body" idx="1"/>
-          </p:nvPr>
-        </p:nvSpPr>
-        <p:spPr/>
-        <p:txBody>
-          <a:bodyPr xmlns:a="http://schemas.openxmlformats.org/drawingml/2006/main"/>
-          <a:lstStyle xmlns:a="http://schemas.openxmlformats.org/drawingml/2006/main"/>
-          <a:p xmlns:a="http://schemas.openxmlformats.org/drawingml/2006/main">
-            <a:r>
-              <a:t>约1分钟。过去资料和偏样本限制结果的适用性；没有路线优化和实时营业状态。MS3先建立独立人工标签，再训练小reranker，记录实验并做API部署计划。与TF确认hybrid项目的评估路线。课程要求分支milestone2以及Canvas完整hash，不在演示时声称已提交Canvas。Sources: docs/DATA.md; docs/DEMO.md; https://harvard-iacs.github.io/2026-AC215/milestone2/.</a:t>
-            </a:r>
-          </a:p>
-        </p:txBody>
-      </p:sp>
-      <p:sp>
-        <p:nvSpPr>
-          <p:cNvPr id="4" name="Slide Number Placeholder 3"/>
-          <p:cNvSpPr>
-            <a:spLocks xmlns:a="http://schemas.openxmlformats.org/drawingml/2006/main" noGrp="1"/>
-          </p:cNvSpPr>
-          <p:nvPr>
-            <p:ph type="sldNum" idx="5"/>
-          </p:nvPr>
-        </p:nvSpPr>
-        <p:spPr/>
-        <p:txBody>
-          <a:bodyPr xmlns:a="http://schemas.openxmlformats.org/drawingml/2006/main"/>
-          <a:lstStyle xmlns:a="http://schemas.openxmlformats.org/drawingml/2006/main"/>
-          <a:p xmlns:a="http://schemas.openxmlformats.org/drawingml/2006/main"/>
-        </p:txBody>
-      </p:sp>
-    </p:spTree>
-  </p:cSld>
-  <p:clrMapOvr>
-    <a:masterClrMapping xmlns:a="http://schemas.openxmlformats.org/drawingml/2006/main"/>
-  </p:clrMapOvr>
-</p:notes>
+<ns0:notes xmlns:ns0="http://schemas.openxmlformats.org/presentationml/2006/main" xmlns:ns1="http://schemas.openxmlformats.org/drawingml/2006/main">
+  <ns0:cSld>
+    <ns0:spTree>
+      <ns0:nvGrpSpPr>
+        <ns0:cNvPr id="1" name=""/>
+        <ns0:cNvGrpSpPr/>
+        <ns0:nvPr/>
+      </ns0:nvGrpSpPr>
+      <ns0:grpSpPr>
+        <ns1:xfrm/>
+      </ns0:grpSpPr>
+      <ns0:sp>
+        <ns0:nvSpPr>
+          <ns0:cNvPr id="2" name="Slide Image Placeholder 1"/>
+          <ns0:cNvSpPr>
+            <ns1:spLocks noGrp="1"/>
+          </ns0:cNvSpPr>
+          <ns0:nvPr>
+            <ns0:ph type="sldImg" idx="0"/>
+          </ns0:nvPr>
+        </ns0:nvSpPr>
+        <ns0:spPr/>
+      </ns0:sp>
+      <ns0:sp>
+        <ns0:nvSpPr>
+          <ns0:cNvPr id="3" name="Notes Placeholder 2"/>
+          <ns0:cNvSpPr>
+            <ns1:spLocks noGrp="1"/>
+          </ns0:cNvSpPr>
+          <ns0:nvPr>
+            <ns0:ph type="body" idx="1"/>
+          </ns0:nvPr>
+        </ns0:nvSpPr>
+        <ns0:spPr/>
+        <ns0:txBody>
+          <ns1:bodyPr/>
+          <ns1:lstStyle/>
+          <ns1:p>
+            <ns1:r>
+              <ns1:t>About 1 minute. Historical data and popularity-biased sampling limit the results. This slide describes the earlier release and its proposed next steps. Current RAG generation and cloud hosting are covered in separate notes; routing is still estimated. Confirm the hybrid assessment path with the TF. Submit the full milestone2 commit hash on Canvas; do not claim submission before it occurs. Sources: docs/DATA.md; docs/DEMO.md; https://harvard-iacs.github.io/2026-AC215/milestone2/.</ns1:t>
+            </ns1:r>
+          </ns1:p>
+        </ns0:txBody>
+      </ns0:sp>
+      <ns0:sp>
+        <ns0:nvSpPr>
+          <ns0:cNvPr id="4" name="Slide Number Placeholder 3"/>
+          <ns0:cNvSpPr>
+            <ns1:spLocks noGrp="1"/>
+          </ns0:cNvSpPr>
+          <ns0:nvPr>
+            <ns0:ph type="sldNum" idx="5"/>
+          </ns0:nvPr>
+        </ns0:nvSpPr>
+        <ns0:spPr/>
+        <ns0:txBody>
+          <ns1:bodyPr/>
+          <ns1:lstStyle/>
+          <ns1:p/>
+        </ns0:txBody>
+      </ns0:sp>
+    </ns0:spTree>
+  </ns0:cSld>
+  <ns0:clrMapOvr>
+    <ns1:masterClrMapping/>
+  </ns0:clrMapOvr>
+</ns0:notes>
 </file>
 
 <file path=ppt/notesSlides/notesSlide2.xml><?xml version="1.0" encoding="utf-8"?>
-<p:notes xmlns:p="http://schemas.openxmlformats.org/presentationml/2006/main">
-  <p:cSld>
-    <p:spTree>
-      <p:nvGrpSpPr>
-        <p:cNvPr id="1" name=""/>
-        <p:cNvGrpSpPr/>
-        <p:nvPr/>
-      </p:nvGrpSpPr>
-      <p:grpSpPr>
-        <a:xfrm xmlns:a="http://schemas.openxmlformats.org/drawingml/2006/main"/>
-      </p:grpSpPr>
-      <p:sp>
-        <p:nvSpPr>
-          <p:cNvPr id="2" name="Slide Image Placeholder 1"/>
-          <p:cNvSpPr>
-            <a:spLocks xmlns:a="http://schemas.openxmlformats.org/drawingml/2006/main" noGrp="1"/>
-          </p:cNvSpPr>
-          <p:nvPr>
-            <p:ph type="sldImg" idx="0"/>
-          </p:nvPr>
-        </p:nvSpPr>
-        <p:spPr/>
-      </p:sp>
-      <p:sp>
-        <p:nvSpPr>
-          <p:cNvPr id="3" name="Notes Placeholder 2"/>
-          <p:cNvSpPr>
-            <a:spLocks xmlns:a="http://schemas.openxmlformats.org/drawingml/2006/main" noGrp="1"/>
-          </p:cNvSpPr>
-          <p:nvPr>
-            <p:ph type="body" idx="1"/>
-          </p:nvPr>
-        </p:nvSpPr>
-        <p:spPr/>
-        <p:txBody>
-          <a:bodyPr xmlns:a="http://schemas.openxmlformats.org/drawingml/2006/main"/>
-          <a:lstStyle xmlns:a="http://schemas.openxmlformats.org/drawingml/2006/main"/>
-          <a:p xmlns:a="http://schemas.openxmlformats.org/drawingml/2006/main">
-            <a:r>
-              <a:t>约1分钟。输入英文兴趣、城市和可选类别；输出地点和来源片段。检索来自真实 API，没有生成完整行程。Screenshot: evidence/app-overview.png.</a:t>
-            </a:r>
-          </a:p>
-        </p:txBody>
-      </p:sp>
-      <p:sp>
-        <p:nvSpPr>
-          <p:cNvPr id="4" name="Slide Number Placeholder 3"/>
-          <p:cNvSpPr>
-            <a:spLocks xmlns:a="http://schemas.openxmlformats.org/drawingml/2006/main" noGrp="1"/>
-          </p:cNvSpPr>
-          <p:nvPr>
-            <p:ph type="sldNum" idx="5"/>
-          </p:nvPr>
-        </p:nvSpPr>
-        <p:spPr/>
-        <p:txBody>
-          <a:bodyPr xmlns:a="http://schemas.openxmlformats.org/drawingml/2006/main"/>
-          <a:lstStyle xmlns:a="http://schemas.openxmlformats.org/drawingml/2006/main"/>
-          <a:p xmlns:a="http://schemas.openxmlformats.org/drawingml/2006/main"/>
-        </p:txBody>
-      </p:sp>
-    </p:spTree>
-  </p:cSld>
-  <p:clrMapOvr>
-    <a:masterClrMapping xmlns:a="http://schemas.openxmlformats.org/drawingml/2006/main"/>
-  </p:clrMapOvr>
-</p:notes>
+<ns0:notes xmlns:ns0="http://schemas.openxmlformats.org/presentationml/2006/main" xmlns:ns1="http://schemas.openxmlformats.org/drawingml/2006/main">
+  <ns0:cSld>
+    <ns0:spTree>
+      <ns0:nvGrpSpPr>
+        <ns0:cNvPr id="1" name=""/>
+        <ns0:cNvGrpSpPr/>
+        <ns0:nvPr/>
+      </ns0:nvGrpSpPr>
+      <ns0:grpSpPr>
+        <ns1:xfrm/>
+      </ns0:grpSpPr>
+      <ns0:sp>
+        <ns0:nvSpPr>
+          <ns0:cNvPr id="2" name="Slide Image Placeholder 1"/>
+          <ns0:cNvSpPr>
+            <ns1:spLocks noGrp="1"/>
+          </ns0:cNvSpPr>
+          <ns0:nvPr>
+            <ns0:ph type="sldImg" idx="0"/>
+          </ns0:nvPr>
+        </ns0:nvSpPr>
+        <ns0:spPr/>
+      </ns0:sp>
+      <ns0:sp>
+        <ns0:nvSpPr>
+          <ns0:cNvPr id="3" name="Notes Placeholder 2"/>
+          <ns0:cNvSpPr>
+            <ns1:spLocks noGrp="1"/>
+          </ns0:cNvSpPr>
+          <ns0:nvPr>
+            <ns0:ph type="body" idx="1"/>
+          </ns0:nvPr>
+        </ns0:nvSpPr>
+        <ns0:spPr/>
+        <ns0:txBody>
+          <ns1:bodyPr/>
+          <ns1:lstStyle/>
+          <ns1:p>
+            <ns1:r>
+              <ns1:t>About 1 minute. The earlier app accepts English interests, a city and an optional category. Its API returns places and source passages. It does not generate an itinerary. Screenshot: evidence/app-overview.png. The current RAG app is documented separately.</ns1:t>
+            </ns1:r>
+          </ns1:p>
+        </ns0:txBody>
+      </ns0:sp>
+      <ns0:sp>
+        <ns0:nvSpPr>
+          <ns0:cNvPr id="4" name="Slide Number Placeholder 3"/>
+          <ns0:cNvSpPr>
+            <ns1:spLocks noGrp="1"/>
+          </ns0:cNvSpPr>
+          <ns0:nvPr>
+            <ns0:ph type="sldNum" idx="5"/>
+          </ns0:nvPr>
+        </ns0:nvSpPr>
+        <ns0:spPr/>
+        <ns0:txBody>
+          <ns1:bodyPr/>
+          <ns1:lstStyle/>
+          <ns1:p/>
+        </ns0:txBody>
+      </ns0:sp>
+    </ns0:spTree>
+  </ns0:cSld>
+  <ns0:clrMapOvr>
+    <ns1:masterClrMapping/>
+  </ns0:clrMapOvr>
+</ns0:notes>
 </file>
 
 <file path=ppt/notesSlides/notesSlide3.xml><?xml version="1.0" encoding="utf-8"?>
-<p:notes xmlns:p="http://schemas.openxmlformats.org/presentationml/2006/main">
-  <p:cSld>
-    <p:spTree>
-      <p:nvGrpSpPr>
-        <p:cNvPr id="1" name=""/>
-        <p:cNvGrpSpPr/>
-        <p:nvPr/>
-      </p:nvGrpSpPr>
-      <p:grpSpPr>
-        <a:xfrm xmlns:a="http://schemas.openxmlformats.org/drawingml/2006/main"/>
-      </p:grpSpPr>
-      <p:sp>
-        <p:nvSpPr>
-          <p:cNvPr id="2" name="Slide Image Placeholder 1"/>
-          <p:cNvSpPr>
-            <a:spLocks xmlns:a="http://schemas.openxmlformats.org/drawingml/2006/main" noGrp="1"/>
-          </p:cNvSpPr>
-          <p:nvPr>
-            <p:ph type="sldImg" idx="0"/>
-          </p:nvPr>
-        </p:nvSpPr>
-        <p:spPr/>
-      </p:sp>
-      <p:sp>
-        <p:nvSpPr>
-          <p:cNvPr id="3" name="Notes Placeholder 2"/>
-          <p:cNvSpPr>
-            <a:spLocks xmlns:a="http://schemas.openxmlformats.org/drawingml/2006/main" noGrp="1"/>
-          </p:cNvSpPr>
-          <p:nvPr>
-            <p:ph type="body" idx="1"/>
-          </p:nvPr>
-        </p:nvSpPr>
-        <p:spPr/>
-        <p:txBody>
-          <a:bodyPr xmlns:a="http://schemas.openxmlformats.org/drawingml/2006/main"/>
-          <a:lstStyle xmlns:a="http://schemas.openxmlformats.org/drawingml/2006/main"/>
-          <a:p xmlns:a="http://schemas.openxmlformats.org/drawingml/2006/main">
-            <a:r>
-              <a:t>约1分钟。原始文件为 UCSD Google Local 2021 Massachusetts，92,520 地点行、10,447,007 评论行。这里展示的是本次从原始文件重新处理的子集，不是之前 Excel 报告的筛选结果。每类125个地点，每个最多6条评论；按评论数取热门地点，有抽样偏差。Sources: https://mcauleylab.ucsd.edu/public_datasets/gdrive/googlelocal/ ; evidence/dataset-manifest.json.</a:t>
-            </a:r>
-          </a:p>
-        </p:txBody>
-      </p:sp>
-      <p:sp>
-        <p:nvSpPr>
-          <p:cNvPr id="4" name="Slide Number Placeholder 3"/>
-          <p:cNvSpPr>
-            <a:spLocks xmlns:a="http://schemas.openxmlformats.org/drawingml/2006/main" noGrp="1"/>
-          </p:cNvSpPr>
-          <p:nvPr>
-            <p:ph type="sldNum" idx="5"/>
-          </p:nvPr>
-        </p:nvSpPr>
-        <p:spPr/>
-        <p:txBody>
-          <a:bodyPr xmlns:a="http://schemas.openxmlformats.org/drawingml/2006/main"/>
-          <a:lstStyle xmlns:a="http://schemas.openxmlformats.org/drawingml/2006/main"/>
-          <a:p xmlns:a="http://schemas.openxmlformats.org/drawingml/2006/main"/>
-        </p:txBody>
-      </p:sp>
-    </p:spTree>
-  </p:cSld>
-  <p:clrMapOvr>
-    <a:masterClrMapping xmlns:a="http://schemas.openxmlformats.org/drawingml/2006/main"/>
-  </p:clrMapOvr>
-</p:notes>
+<ns0:notes xmlns:ns0="http://schemas.openxmlformats.org/presentationml/2006/main" xmlns:ns1="http://schemas.openxmlformats.org/drawingml/2006/main">
+  <ns0:cSld>
+    <ns0:spTree>
+      <ns0:nvGrpSpPr>
+        <ns0:cNvPr id="1" name=""/>
+        <ns0:cNvGrpSpPr/>
+        <ns0:nvPr/>
+      </ns0:nvGrpSpPr>
+      <ns0:grpSpPr>
+        <ns1:xfrm/>
+      </ns0:grpSpPr>
+      <ns0:sp>
+        <ns0:nvSpPr>
+          <ns0:cNvPr id="2" name="Slide Image Placeholder 1"/>
+          <ns0:cNvSpPr>
+            <ns1:spLocks noGrp="1"/>
+          </ns0:cNvSpPr>
+          <ns0:nvPr>
+            <ns0:ph type="sldImg" idx="0"/>
+          </ns0:nvPr>
+        </ns0:nvSpPr>
+        <ns0:spPr/>
+      </ns0:sp>
+      <ns0:sp>
+        <ns0:nvSpPr>
+          <ns0:cNvPr id="3" name="Notes Placeholder 2"/>
+          <ns0:cNvSpPr>
+            <ns1:spLocks noGrp="1"/>
+          </ns0:cNvSpPr>
+          <ns0:nvPr>
+            <ns0:ph type="body" idx="1"/>
+          </ns0:nvPr>
+        </ns0:nvSpPr>
+        <ns0:spPr/>
+        <ns0:txBody>
+          <ns1:bodyPr/>
+          <ns1:lstStyle/>
+          <ns1:p>
+            <ns1:r>
+              <ns1:t>About 1 minute. The source is UCSD Google Local 2021 for Massachusetts: 92,520 metadata rows and 10,447,007 review rows. The pilot was rebuilt from those files. It keeps up to 125 places per category and six reviews per place. Selecting popular places introduces sampling bias. Sources: https://mcauleylab.ucsd.edu/public_datasets/gdrive/googlelocal/ ; evidence/dataset-manifest.json.</ns1:t>
+            </ns1:r>
+          </ns1:p>
+        </ns0:txBody>
+      </ns0:sp>
+      <ns0:sp>
+        <ns0:nvSpPr>
+          <ns0:cNvPr id="4" name="Slide Number Placeholder 3"/>
+          <ns0:cNvSpPr>
+            <ns1:spLocks noGrp="1"/>
+          </ns0:cNvSpPr>
+          <ns0:nvPr>
+            <ns0:ph type="sldNum" idx="5"/>
+          </ns0:nvPr>
+        </ns0:nvSpPr>
+        <ns0:spPr/>
+        <ns0:txBody>
+          <ns1:bodyPr/>
+          <ns1:lstStyle/>
+          <ns1:p/>
+        </ns0:txBody>
+      </ns0:sp>
+    </ns0:spTree>
+  </ns0:cSld>
+  <ns0:clrMapOvr>
+    <ns1:masterClrMapping/>
+  </ns0:clrMapOvr>
+</ns0:notes>
 </file>
 
 <file path=ppt/notesSlides/notesSlide4.xml><?xml version="1.0" encoding="utf-8"?>
-<p:notes xmlns:p="http://schemas.openxmlformats.org/presentationml/2006/main">
-  <p:cSld>
-    <p:spTree>
-      <p:nvGrpSpPr>
-        <p:cNvPr id="1" name=""/>
-        <p:cNvGrpSpPr/>
-        <p:nvPr/>
-      </p:nvGrpSpPr>
-      <p:grpSpPr>
-        <a:xfrm xmlns:a="http://schemas.openxmlformats.org/drawingml/2006/main"/>
-      </p:grpSpPr>
-      <p:sp>
-        <p:nvSpPr>
-          <p:cNvPr id="2" name="Slide Image Placeholder 1"/>
-          <p:cNvSpPr>
-            <a:spLocks xmlns:a="http://schemas.openxmlformats.org/drawingml/2006/main" noGrp="1"/>
-          </p:cNvSpPr>
-          <p:nvPr>
-            <p:ph type="sldImg" idx="0"/>
-          </p:nvPr>
-        </p:nvSpPr>
-        <p:spPr/>
-      </p:sp>
-      <p:sp>
-        <p:nvSpPr>
-          <p:cNvPr id="3" name="Notes Placeholder 2"/>
-          <p:cNvSpPr>
-            <a:spLocks xmlns:a="http://schemas.openxmlformats.org/drawingml/2006/main" noGrp="1"/>
-          </p:cNvSpPr>
-          <p:nvPr>
-            <p:ph type="body" idx="1"/>
-          </p:nvPr>
-        </p:nvSpPr>
-        <p:spPr/>
-        <p:txBody>
-          <a:bodyPr xmlns:a="http://schemas.openxmlformats.org/drawingml/2006/main"/>
-          <a:lstStyle xmlns:a="http://schemas.openxmlformats.org/drawingml/2006/main"/>
-          <a:p xmlns:a="http://schemas.openxmlformats.org/drawingml/2006/main">
-            <a:r>
-              <a:t>约1.5分钟。打开 compose.yaml 解释 service_completed_successfully 和 service_healthy；每个 Python 步骤独立 Dockerfile、pyproject 和 uv.lock。数据与模型用 volume 保存。CPU运算和测试也在容器中。Source: compose.yaml; services/*/Dockerfile.</a:t>
-            </a:r>
-          </a:p>
-        </p:txBody>
-      </p:sp>
-      <p:sp>
-        <p:nvSpPr>
-          <p:cNvPr id="4" name="Slide Number Placeholder 3"/>
-          <p:cNvSpPr>
-            <a:spLocks xmlns:a="http://schemas.openxmlformats.org/drawingml/2006/main" noGrp="1"/>
-          </p:cNvSpPr>
-          <p:nvPr>
-            <p:ph type="sldNum" idx="5"/>
-          </p:nvPr>
-        </p:nvSpPr>
-        <p:spPr/>
-        <p:txBody>
-          <a:bodyPr xmlns:a="http://schemas.openxmlformats.org/drawingml/2006/main"/>
-          <a:lstStyle xmlns:a="http://schemas.openxmlformats.org/drawingml/2006/main"/>
-          <a:p xmlns:a="http://schemas.openxmlformats.org/drawingml/2006/main"/>
-        </p:txBody>
-      </p:sp>
-    </p:spTree>
-  </p:cSld>
-  <p:clrMapOvr>
-    <a:masterClrMapping xmlns:a="http://schemas.openxmlformats.org/drawingml/2006/main"/>
-  </p:clrMapOvr>
-</p:notes>
+<ns0:notes xmlns:ns0="http://schemas.openxmlformats.org/presentationml/2006/main" xmlns:ns1="http://schemas.openxmlformats.org/drawingml/2006/main">
+  <ns0:cSld>
+    <ns0:spTree>
+      <ns0:nvGrpSpPr>
+        <ns0:cNvPr id="1" name=""/>
+        <ns0:cNvGrpSpPr/>
+        <ns0:nvPr/>
+      </ns0:nvGrpSpPr>
+      <ns0:grpSpPr>
+        <ns1:xfrm/>
+      </ns0:grpSpPr>
+      <ns0:sp>
+        <ns0:nvSpPr>
+          <ns0:cNvPr id="2" name="Slide Image Placeholder 1"/>
+          <ns0:cNvSpPr>
+            <ns1:spLocks noGrp="1"/>
+          </ns0:cNvSpPr>
+          <ns0:nvPr>
+            <ns0:ph type="sldImg" idx="0"/>
+          </ns0:nvPr>
+        </ns0:nvSpPr>
+        <ns0:spPr/>
+      </ns0:sp>
+      <ns0:sp>
+        <ns0:nvSpPr>
+          <ns0:cNvPr id="3" name="Notes Placeholder 2"/>
+          <ns0:cNvSpPr>
+            <ns1:spLocks noGrp="1"/>
+          </ns0:cNvSpPr>
+          <ns0:nvPr>
+            <ns0:ph type="body" idx="1"/>
+          </ns0:nvPr>
+        </ns0:nvSpPr>
+        <ns0:spPr/>
+        <ns0:txBody>
+          <ns1:bodyPr/>
+          <ns1:lstStyle/>
+          <ns1:p>
+            <ns1:r>
+              <ns1:t>About 90 seconds. Open compose.yaml and explain service_completed_successfully and service_healthy. Each Python service has a Dockerfile, pyproject.toml and uv.lock. Volumes retain data and model files. CPU computation and tests run in containers. Sources: compose.yaml; services/*/Dockerfile.</ns1:t>
+            </ns1:r>
+          </ns1:p>
+        </ns0:txBody>
+      </ns0:sp>
+      <ns0:sp>
+        <ns0:nvSpPr>
+          <ns0:cNvPr id="4" name="Slide Number Placeholder 3"/>
+          <ns0:cNvSpPr>
+            <ns1:spLocks noGrp="1"/>
+          </ns0:cNvSpPr>
+          <ns0:nvPr>
+            <ns0:ph type="sldNum" idx="5"/>
+          </ns0:nvPr>
+        </ns0:nvSpPr>
+        <ns0:spPr/>
+        <ns0:txBody>
+          <ns1:bodyPr/>
+          <ns1:lstStyle/>
+          <ns1:p/>
+        </ns0:txBody>
+      </ns0:sp>
+    </ns0:spTree>
+  </ns0:cSld>
+  <ns0:clrMapOvr>
+    <ns1:masterClrMapping/>
+  </ns0:clrMapOvr>
+</ns0:notes>
 </file>
 
 <file path=ppt/notesSlides/notesSlide5.xml><?xml version="1.0" encoding="utf-8"?>
-<p:notes xmlns:p="http://schemas.openxmlformats.org/presentationml/2006/main">
-  <p:cSld>
-    <p:spTree>
-      <p:nvGrpSpPr>
-        <p:cNvPr id="1" name=""/>
-        <p:cNvGrpSpPr/>
-        <p:nvPr/>
-      </p:nvGrpSpPr>
-      <p:grpSpPr>
-        <a:xfrm xmlns:a="http://schemas.openxmlformats.org/drawingml/2006/main"/>
-      </p:grpSpPr>
-      <p:sp>
-        <p:nvSpPr>
-          <p:cNvPr id="2" name="Slide Image Placeholder 1"/>
-          <p:cNvSpPr>
-            <a:spLocks xmlns:a="http://schemas.openxmlformats.org/drawingml/2006/main" noGrp="1"/>
-          </p:cNvSpPr>
-          <p:nvPr>
-            <p:ph type="sldImg" idx="0"/>
-          </p:nvPr>
-        </p:nvSpPr>
-        <p:spPr/>
-      </p:sp>
-      <p:sp>
-        <p:nvSpPr>
-          <p:cNvPr id="3" name="Notes Placeholder 2"/>
-          <p:cNvSpPr>
-            <a:spLocks xmlns:a="http://schemas.openxmlformats.org/drawingml/2006/main" noGrp="1"/>
-          </p:cNvSpPr>
-          <p:nvPr>
-            <p:ph type="body" idx="1"/>
-          </p:nvPr>
-        </p:nvSpPr>
-        <p:spPr/>
-        <p:txBody>
-          <a:bodyPr xmlns:a="http://schemas.openxmlformats.org/drawingml/2006/main"/>
-          <a:lstStyle xmlns:a="http://schemas.openxmlformats.org/drawingml/2006/main"/>
-          <a:p xmlns:a="http://schemas.openxmlformats.org/drawingml/2006/main">
-            <a:r>
-              <a:t>约1分钟。Docker 固定运行环境，uv.lock 固定 Python 依赖。数据校验与模型校验是不同层次。缓存使用前验证，数据/参数变更触发重建。Dockerfile 的每行要能解释。Sources: config/sources.json; services/index/Dockerfile; evidence/index-manifest.json.</a:t>
-            </a:r>
-          </a:p>
-        </p:txBody>
-      </p:sp>
-      <p:sp>
-        <p:nvSpPr>
-          <p:cNvPr id="4" name="Slide Number Placeholder 3"/>
-          <p:cNvSpPr>
-            <a:spLocks xmlns:a="http://schemas.openxmlformats.org/drawingml/2006/main" noGrp="1"/>
-          </p:cNvSpPr>
-          <p:nvPr>
-            <p:ph type="sldNum" idx="5"/>
-          </p:nvPr>
-        </p:nvSpPr>
-        <p:spPr/>
-        <p:txBody>
-          <a:bodyPr xmlns:a="http://schemas.openxmlformats.org/drawingml/2006/main"/>
-          <a:lstStyle xmlns:a="http://schemas.openxmlformats.org/drawingml/2006/main"/>
-          <a:p xmlns:a="http://schemas.openxmlformats.org/drawingml/2006/main"/>
-        </p:txBody>
-      </p:sp>
-    </p:spTree>
-  </p:cSld>
-  <p:clrMapOvr>
-    <a:masterClrMapping xmlns:a="http://schemas.openxmlformats.org/drawingml/2006/main"/>
-  </p:clrMapOvr>
-</p:notes>
+<ns0:notes xmlns:ns0="http://schemas.openxmlformats.org/presentationml/2006/main" xmlns:ns1="http://schemas.openxmlformats.org/drawingml/2006/main">
+  <ns0:cSld>
+    <ns0:spTree>
+      <ns0:nvGrpSpPr>
+        <ns0:cNvPr id="1" name=""/>
+        <ns0:cNvGrpSpPr/>
+        <ns0:nvPr/>
+      </ns0:nvGrpSpPr>
+      <ns0:grpSpPr>
+        <ns1:xfrm/>
+      </ns0:grpSpPr>
+      <ns0:sp>
+        <ns0:nvSpPr>
+          <ns0:cNvPr id="2" name="Slide Image Placeholder 1"/>
+          <ns0:cNvSpPr>
+            <ns1:spLocks noGrp="1"/>
+          </ns0:cNvSpPr>
+          <ns0:nvPr>
+            <ns0:ph type="sldImg" idx="0"/>
+          </ns0:nvPr>
+        </ns0:nvSpPr>
+        <ns0:spPr/>
+      </ns0:sp>
+      <ns0:sp>
+        <ns0:nvSpPr>
+          <ns0:cNvPr id="3" name="Notes Placeholder 2"/>
+          <ns0:cNvSpPr>
+            <ns1:spLocks noGrp="1"/>
+          </ns0:cNvSpPr>
+          <ns0:nvPr>
+            <ns0:ph type="body" idx="1"/>
+          </ns0:nvPr>
+        </ns0:nvSpPr>
+        <ns0:spPr/>
+        <ns0:txBody>
+          <ns1:bodyPr/>
+          <ns1:lstStyle/>
+          <ns1:p>
+            <ns1:r>
+              <ns1:t>About 1 minute. Docker fixes the runtime environment; uv.lock fixes Python dependencies. Data and model checksums serve different purposes. Validate caches before reuse. Changes to data or processing parameters require a rebuild. Sources: config/sources.json; services/index/Dockerfile; evidence/index-manifest.json.</ns1:t>
+            </ns1:r>
+          </ns1:p>
+        </ns0:txBody>
+      </ns0:sp>
+      <ns0:sp>
+        <ns0:nvSpPr>
+          <ns0:cNvPr id="4" name="Slide Number Placeholder 3"/>
+          <ns0:cNvSpPr>
+            <ns1:spLocks noGrp="1"/>
+          </ns0:cNvSpPr>
+          <ns0:nvPr>
+            <ns0:ph type="sldNum" idx="5"/>
+          </ns0:nvPr>
+        </ns0:nvSpPr>
+        <ns0:spPr/>
+        <ns0:txBody>
+          <ns1:bodyPr/>
+          <ns1:lstStyle/>
+          <ns1:p/>
+        </ns0:txBody>
+      </ns0:sp>
+    </ns0:spTree>
+  </ns0:cSld>
+  <ns0:clrMapOvr>
+    <ns1:masterClrMapping/>
+  </ns0:clrMapOvr>
+</ns0:notes>
 </file>
 
 <file path=ppt/notesSlides/notesSlide6.xml><?xml version="1.0" encoding="utf-8"?>
-<p:notes xmlns:p="http://schemas.openxmlformats.org/presentationml/2006/main">
-  <p:cSld>
-    <p:spTree>
-      <p:nvGrpSpPr>
-        <p:cNvPr id="1" name=""/>
-        <p:cNvGrpSpPr/>
-        <p:nvPr/>
-      </p:nvGrpSpPr>
-      <p:grpSpPr>
-        <a:xfrm xmlns:a="http://schemas.openxmlformats.org/drawingml/2006/main"/>
-      </p:grpSpPr>
-      <p:sp>
-        <p:nvSpPr>
-          <p:cNvPr id="2" name="Slide Image Placeholder 1"/>
-          <p:cNvSpPr>
-            <a:spLocks xmlns:a="http://schemas.openxmlformats.org/drawingml/2006/main" noGrp="1"/>
-          </p:cNvSpPr>
-          <p:nvPr>
-            <p:ph type="sldImg" idx="0"/>
-          </p:nvPr>
-        </p:nvSpPr>
-        <p:spPr/>
-      </p:sp>
-      <p:sp>
-        <p:nvSpPr>
-          <p:cNvPr id="3" name="Notes Placeholder 2"/>
-          <p:cNvSpPr>
-            <a:spLocks xmlns:a="http://schemas.openxmlformats.org/drawingml/2006/main" noGrp="1"/>
-          </p:cNvSpPr>
-          <p:nvPr>
-            <p:ph type="body" idx="1"/>
-          </p:nvPr>
-        </p:nvSpPr>
-        <p:spPr/>
-        <p:txBody>
-          <a:bodyPr xmlns:a="http://schemas.openxmlformats.org/drawingml/2006/main"/>
-          <a:lstStyle xmlns:a="http://schemas.openxmlformats.org/drawingml/2006/main"/>
-          <a:p xmlns:a="http://schemas.openxmlformats.org/drawingml/2006/main">
-            <a:r>
-              <a:t>约1分钟。展示保存的 sample-input.json 和 sample-output.json。Harvard Art Museums 排名第一；点击来源可以查看评论文件行号。相似度不是概率。输出context可供未来生成器使用，本版本没有生成式LLM。Sources: evidence/sample-input.json; evidence/sample-output.json; https://huggingface.co/sentence-transformers/all-MiniLM-L6-v2.</a:t>
-            </a:r>
-          </a:p>
-        </p:txBody>
-      </p:sp>
-      <p:sp>
-        <p:nvSpPr>
-          <p:cNvPr id="4" name="Slide Number Placeholder 3"/>
-          <p:cNvSpPr>
-            <a:spLocks xmlns:a="http://schemas.openxmlformats.org/drawingml/2006/main" noGrp="1"/>
-          </p:cNvSpPr>
-          <p:nvPr>
-            <p:ph type="sldNum" idx="5"/>
-          </p:nvPr>
-        </p:nvSpPr>
-        <p:spPr/>
-        <p:txBody>
-          <a:bodyPr xmlns:a="http://schemas.openxmlformats.org/drawingml/2006/main"/>
-          <a:lstStyle xmlns:a="http://schemas.openxmlformats.org/drawingml/2006/main"/>
-          <a:p xmlns:a="http://schemas.openxmlformats.org/drawingml/2006/main"/>
-        </p:txBody>
-      </p:sp>
-    </p:spTree>
-  </p:cSld>
-  <p:clrMapOvr>
-    <a:masterClrMapping xmlns:a="http://schemas.openxmlformats.org/drawingml/2006/main"/>
-  </p:clrMapOvr>
-</p:notes>
+<ns0:notes xmlns:ns0="http://schemas.openxmlformats.org/presentationml/2006/main" xmlns:ns1="http://schemas.openxmlformats.org/drawingml/2006/main">
+  <ns0:cSld>
+    <ns0:spTree>
+      <ns0:nvGrpSpPr>
+        <ns0:cNvPr id="1" name=""/>
+        <ns0:cNvGrpSpPr/>
+        <ns0:nvPr/>
+      </ns0:nvGrpSpPr>
+      <ns0:grpSpPr>
+        <ns1:xfrm/>
+      </ns0:grpSpPr>
+      <ns0:sp>
+        <ns0:nvSpPr>
+          <ns0:cNvPr id="2" name="Slide Image Placeholder 1"/>
+          <ns0:cNvSpPr>
+            <ns1:spLocks noGrp="1"/>
+          </ns0:cNvSpPr>
+          <ns0:nvPr>
+            <ns0:ph type="sldImg" idx="0"/>
+          </ns0:nvPr>
+        </ns0:nvSpPr>
+        <ns0:spPr/>
+      </ns0:sp>
+      <ns0:sp>
+        <ns0:nvSpPr>
+          <ns0:cNvPr id="3" name="Notes Placeholder 2"/>
+          <ns0:cNvSpPr>
+            <ns1:spLocks noGrp="1"/>
+          </ns0:cNvSpPr>
+          <ns0:nvPr>
+            <ns0:ph type="body" idx="1"/>
+          </ns0:nvPr>
+        </ns0:nvSpPr>
+        <ns0:spPr/>
+        <ns0:txBody>
+          <ns1:bodyPr/>
+          <ns1:lstStyle/>
+          <ns1:p>
+            <ns1:r>
+              <ns1:t>About 1 minute. Show sample-input.json and sample-output.json. Harvard Art Museums ranks first in this saved example. Each passage has a source file and line. Similarity is not a probability. This earlier release returns context without a generative LLM. Sources: evidence/sample-input.json; evidence/sample-output.json; https://huggingface.co/sentence-transformers/all-MiniLM-L6-v2.</ns1:t>
+            </ns1:r>
+          </ns1:p>
+        </ns0:txBody>
+      </ns0:sp>
+      <ns0:sp>
+        <ns0:nvSpPr>
+          <ns0:cNvPr id="4" name="Slide Number Placeholder 3"/>
+          <ns0:cNvSpPr>
+            <ns1:spLocks noGrp="1"/>
+          </ns0:cNvSpPr>
+          <ns0:nvPr>
+            <ns0:ph type="sldNum" idx="5"/>
+          </ns0:nvPr>
+        </ns0:nvSpPr>
+        <ns0:spPr/>
+        <ns0:txBody>
+          <ns1:bodyPr/>
+          <ns1:lstStyle/>
+          <ns1:p/>
+        </ns0:txBody>
+      </ns0:sp>
+    </ns0:spTree>
+  </ns0:cSld>
+  <ns0:clrMapOvr>
+    <ns1:masterClrMapping/>
+  </ns0:clrMapOvr>
+</ns0:notes>
 </file>
 
 <file path=ppt/notesSlides/notesSlide7.xml><?xml version="1.0" encoding="utf-8"?>
-<p:notes xmlns:p="http://schemas.openxmlformats.org/presentationml/2006/main">
-  <p:cSld>
-    <p:spTree>
-      <p:nvGrpSpPr>
-        <p:cNvPr id="1" name=""/>
-        <p:cNvGrpSpPr/>
-        <p:nvPr/>
-      </p:nvGrpSpPr>
-      <p:grpSpPr>
-        <a:xfrm xmlns:a="http://schemas.openxmlformats.org/drawingml/2006/main"/>
-      </p:grpSpPr>
-      <p:sp>
-        <p:nvSpPr>
-          <p:cNvPr id="2" name="Slide Image Placeholder 1"/>
-          <p:cNvSpPr>
-            <a:spLocks xmlns:a="http://schemas.openxmlformats.org/drawingml/2006/main" noGrp="1"/>
-          </p:cNvSpPr>
-          <p:nvPr>
-            <p:ph type="sldImg" idx="0"/>
-          </p:nvPr>
-        </p:nvSpPr>
-        <p:spPr/>
-      </p:sp>
-      <p:sp>
-        <p:nvSpPr>
-          <p:cNvPr id="3" name="Notes Placeholder 2"/>
-          <p:cNvSpPr>
-            <a:spLocks xmlns:a="http://schemas.openxmlformats.org/drawingml/2006/main" noGrp="1"/>
-          </p:cNvSpPr>
-          <p:nvPr>
-            <p:ph type="body" idx="1"/>
-          </p:nvPr>
-        </p:nvSpPr>
-        <p:spPr/>
-        <p:txBody>
-          <a:bodyPr xmlns:a="http://schemas.openxmlformats.org/drawingml/2006/main"/>
-          <a:lstStyle xmlns:a="http://schemas.openxmlformats.org/drawingml/2006/main"/>
-          <a:p xmlns:a="http://schemas.openxmlformats.org/drawingml/2006/main">
-            <a:r>
-              <a:t>约1.5分钟现场演示。查询博物馆，切换baseline，查看来源，保存一个地点并导出。若演示电脑不在本机，先git clone并运行。Screenshot: evidence/app-search.png; source: frontend/app.js.</a:t>
-            </a:r>
-          </a:p>
-        </p:txBody>
-      </p:sp>
-      <p:sp>
-        <p:nvSpPr>
-          <p:cNvPr id="4" name="Slide Number Placeholder 3"/>
-          <p:cNvSpPr>
-            <a:spLocks xmlns:a="http://schemas.openxmlformats.org/drawingml/2006/main" noGrp="1"/>
-          </p:cNvSpPr>
-          <p:nvPr>
-            <p:ph type="sldNum" idx="5"/>
-          </p:nvPr>
-        </p:nvSpPr>
-        <p:spPr/>
-        <p:txBody>
-          <a:bodyPr xmlns:a="http://schemas.openxmlformats.org/drawingml/2006/main"/>
-          <a:lstStyle xmlns:a="http://schemas.openxmlformats.org/drawingml/2006/main"/>
-          <a:p xmlns:a="http://schemas.openxmlformats.org/drawingml/2006/main"/>
-        </p:txBody>
-      </p:sp>
-    </p:spTree>
-  </p:cSld>
-  <p:clrMapOvr>
-    <a:masterClrMapping xmlns:a="http://schemas.openxmlformats.org/drawingml/2006/main"/>
-  </p:clrMapOvr>
-</p:notes>
+<ns0:notes xmlns:ns0="http://schemas.openxmlformats.org/presentationml/2006/main" xmlns:ns1="http://schemas.openxmlformats.org/drawingml/2006/main">
+  <ns0:cSld>
+    <ns0:spTree>
+      <ns0:nvGrpSpPr>
+        <ns0:cNvPr id="1" name=""/>
+        <ns0:cNvGrpSpPr/>
+        <ns0:nvPr/>
+      </ns0:nvGrpSpPr>
+      <ns0:grpSpPr>
+        <ns1:xfrm/>
+      </ns0:grpSpPr>
+      <ns0:sp>
+        <ns0:nvSpPr>
+          <ns0:cNvPr id="2" name="Slide Image Placeholder 1"/>
+          <ns0:cNvSpPr>
+            <ns1:spLocks noGrp="1"/>
+          </ns0:cNvSpPr>
+          <ns0:nvPr>
+            <ns0:ph type="sldImg" idx="0"/>
+          </ns0:nvPr>
+        </ns0:nvSpPr>
+        <ns0:spPr/>
+      </ns0:sp>
+      <ns0:sp>
+        <ns0:nvSpPr>
+          <ns0:cNvPr id="3" name="Notes Placeholder 2"/>
+          <ns0:cNvSpPr>
+            <ns1:spLocks noGrp="1"/>
+          </ns0:cNvSpPr>
+          <ns0:nvPr>
+            <ns0:ph type="body" idx="1"/>
+          </ns0:nvPr>
+        </ns0:nvSpPr>
+        <ns0:spPr/>
+        <ns0:txBody>
+          <ns1:bodyPr/>
+          <ns1:lstStyle/>
+          <ns1:p>
+            <ns1:r>
+              <ns1:t>About 90 seconds. For the earlier retrieval demo, search for museums, compare the baseline, inspect sources, save a place and export. For the current app, follow docs/PRESENTATION_NOTES.md. Screenshot: evidence/app-search.png; source: frontend/app.js.</ns1:t>
+            </ns1:r>
+          </ns1:p>
+        </ns0:txBody>
+      </ns0:sp>
+      <ns0:sp>
+        <ns0:nvSpPr>
+          <ns0:cNvPr id="4" name="Slide Number Placeholder 3"/>
+          <ns0:cNvSpPr>
+            <ns1:spLocks noGrp="1"/>
+          </ns0:cNvSpPr>
+          <ns0:nvPr>
+            <ns0:ph type="sldNum" idx="5"/>
+          </ns0:nvPr>
+        </ns0:nvSpPr>
+        <ns0:spPr/>
+        <ns0:txBody>
+          <ns1:bodyPr/>
+          <ns1:lstStyle/>
+          <ns1:p/>
+        </ns0:txBody>
+      </ns0:sp>
+    </ns0:spTree>
+  </ns0:cSld>
+  <ns0:clrMapOvr>
+    <ns1:masterClrMapping/>
+  </ns0:clrMapOvr>
+</ns0:notes>
 </file>
 
 <file path=ppt/notesSlides/notesSlide8.xml><?xml version="1.0" encoding="utf-8"?>
-<p:notes xmlns:p="http://schemas.openxmlformats.org/presentationml/2006/main">
-  <p:cSld>
-    <p:spTree>
-      <p:nvGrpSpPr>
-        <p:cNvPr id="1" name=""/>
-        <p:cNvGrpSpPr/>
-        <p:nvPr/>
-      </p:nvGrpSpPr>
-      <p:grpSpPr>
-        <a:xfrm xmlns:a="http://schemas.openxmlformats.org/drawingml/2006/main"/>
-      </p:grpSpPr>
-      <p:sp>
-        <p:nvSpPr>
-          <p:cNvPr id="2" name="Slide Image Placeholder 1"/>
-          <p:cNvSpPr>
-            <a:spLocks xmlns:a="http://schemas.openxmlformats.org/drawingml/2006/main" noGrp="1"/>
-          </p:cNvSpPr>
-          <p:nvPr>
-            <p:ph type="sldImg" idx="0"/>
-          </p:nvPr>
-        </p:nvSpPr>
-        <p:spPr/>
-      </p:sp>
-      <p:sp>
-        <p:nvSpPr>
-          <p:cNvPr id="3" name="Notes Placeholder 2"/>
-          <p:cNvSpPr>
-            <a:spLocks xmlns:a="http://schemas.openxmlformats.org/drawingml/2006/main" noGrp="1"/>
-          </p:cNvSpPr>
-          <p:nvPr>
-            <p:ph type="body" idx="1"/>
-          </p:nvPr>
-        </p:nvSpPr>
-        <p:spPr/>
-        <p:txBody>
-          <a:bodyPr xmlns:a="http://schemas.openxmlformats.org/drawingml/2006/main"/>
-          <a:lstStyle xmlns:a="http://schemas.openxmlformats.org/drawingml/2006/main"/>
-          <a:p xmlns:a="http://schemas.openxmlformats.org/drawingml/2006/main">
-            <a:r>
-              <a:t>约1.5分钟。不能把这个表叫人工推荐准确率。20条查询含类别词；类别标签来自预定义问题类别，是自动代理指标。baseline略高是合理结果。语义检索可能理解细节，但当前测量没有充分考察这个优势。不要事后修改查询来提高分数。Source: evaluation/queries.json; evidence/evaluation.json.</a:t>
-            </a:r>
-          </a:p>
-        </p:txBody>
-      </p:sp>
-      <p:sp>
-        <p:nvSpPr>
-          <p:cNvPr id="4" name="Slide Number Placeholder 3"/>
-          <p:cNvSpPr>
-            <a:spLocks xmlns:a="http://schemas.openxmlformats.org/drawingml/2006/main" noGrp="1"/>
-          </p:cNvSpPr>
-          <p:nvPr>
-            <p:ph type="sldNum" idx="5"/>
-          </p:nvPr>
-        </p:nvSpPr>
-        <p:spPr/>
-        <p:txBody>
-          <a:bodyPr xmlns:a="http://schemas.openxmlformats.org/drawingml/2006/main"/>
-          <a:lstStyle xmlns:a="http://schemas.openxmlformats.org/drawingml/2006/main"/>
-          <a:p xmlns:a="http://schemas.openxmlformats.org/drawingml/2006/main"/>
-        </p:txBody>
-      </p:sp>
-    </p:spTree>
-  </p:cSld>
-  <p:clrMapOvr>
-    <a:masterClrMapping xmlns:a="http://schemas.openxmlformats.org/drawingml/2006/main"/>
-  </p:clrMapOvr>
-</p:notes>
+<ns0:notes xmlns:ns0="http://schemas.openxmlformats.org/presentationml/2006/main" xmlns:ns1="http://schemas.openxmlformats.org/drawingml/2006/main">
+  <ns0:cSld>
+    <ns0:spTree>
+      <ns0:nvGrpSpPr>
+        <ns0:cNvPr id="1" name=""/>
+        <ns0:cNvGrpSpPr/>
+        <ns0:nvPr/>
+      </ns0:nvGrpSpPr>
+      <ns0:grpSpPr>
+        <ns1:xfrm/>
+      </ns0:grpSpPr>
+      <ns0:sp>
+        <ns0:nvSpPr>
+          <ns0:cNvPr id="2" name="Slide Image Placeholder 1"/>
+          <ns0:cNvSpPr>
+            <ns1:spLocks noGrp="1"/>
+          </ns0:cNvSpPr>
+          <ns0:nvPr>
+            <ns0:ph type="sldImg" idx="0"/>
+          </ns0:nvPr>
+        </ns0:nvSpPr>
+        <ns0:spPr/>
+      </ns0:sp>
+      <ns0:sp>
+        <ns0:nvSpPr>
+          <ns0:cNvPr id="3" name="Notes Placeholder 2"/>
+          <ns0:cNvSpPr>
+            <ns1:spLocks noGrp="1"/>
+          </ns0:cNvSpPr>
+          <ns0:nvPr>
+            <ns0:ph type="body" idx="1"/>
+          </ns0:nvPr>
+        </ns0:nvSpPr>
+        <ns0:spPr/>
+        <ns0:txBody>
+          <ns1:bodyPr/>
+          <ns1:lstStyle/>
+          <ns1:p>
+            <ns1:r>
+              <ns1:t>About 90 seconds. This is not human recommendation accuracy. The 20 queries contain category words, and the expected categories are proxy labels. That wording favors the baseline. The benchmark does not establish whether semantic retrieval captures finer preferences. Sources: evaluation/queries.json; evidence/evaluation.json.</ns1:t>
+            </ns1:r>
+          </ns1:p>
+        </ns0:txBody>
+      </ns0:sp>
+      <ns0:sp>
+        <ns0:nvSpPr>
+          <ns0:cNvPr id="4" name="Slide Number Placeholder 3"/>
+          <ns0:cNvSpPr>
+            <ns1:spLocks noGrp="1"/>
+          </ns0:cNvSpPr>
+          <ns0:nvPr>
+            <ns0:ph type="sldNum" idx="5"/>
+          </ns0:nvPr>
+        </ns0:nvSpPr>
+        <ns0:spPr/>
+        <ns0:txBody>
+          <ns1:bodyPr/>
+          <ns1:lstStyle/>
+          <ns1:p/>
+        </ns0:txBody>
+      </ns0:sp>
+    </ns0:spTree>
+  </ns0:cSld>
+  <ns0:clrMapOvr>
+    <ns1:masterClrMapping/>
+  </ns0:clrMapOvr>
+</ns0:notes>
 </file>
 
 <file path=ppt/notesSlides/notesSlide9.xml><?xml version="1.0" encoding="utf-8"?>
-<p:notes xmlns:p="http://schemas.openxmlformats.org/presentationml/2006/main">
-  <p:cSld>
-    <p:spTree>
-      <p:nvGrpSpPr>
-        <p:cNvPr id="1" name=""/>
-        <p:cNvGrpSpPr/>
-        <p:nvPr/>
-      </p:nvGrpSpPr>
-      <p:grpSpPr>
-        <a:xfrm xmlns:a="http://schemas.openxmlformats.org/drawingml/2006/main"/>
-      </p:grpSpPr>
-      <p:sp>
-        <p:nvSpPr>
-          <p:cNvPr id="2" name="Slide Image Placeholder 1"/>
-          <p:cNvSpPr>
-            <a:spLocks xmlns:a="http://schemas.openxmlformats.org/drawingml/2006/main" noGrp="1"/>
-          </p:cNvSpPr>
-          <p:nvPr>
-            <p:ph type="sldImg" idx="0"/>
-          </p:nvPr>
-        </p:nvSpPr>
-        <p:spPr/>
-      </p:sp>
-      <p:sp>
-        <p:nvSpPr>
-          <p:cNvPr id="3" name="Notes Placeholder 2"/>
-          <p:cNvSpPr>
-            <a:spLocks xmlns:a="http://schemas.openxmlformats.org/drawingml/2006/main" noGrp="1"/>
-          </p:cNvSpPr>
-          <p:nvPr>
-            <p:ph type="body" idx="1"/>
-          </p:nvPr>
-        </p:nvSpPr>
-        <p:spPr/>
-        <p:txBody>
-          <a:bodyPr xmlns:a="http://schemas.openxmlformats.org/drawingml/2006/main"/>
-          <a:lstStyle xmlns:a="http://schemas.openxmlformats.org/drawingml/2006/main"/>
-          <a:p xmlns:a="http://schemas.openxmlformats.org/drawingml/2006/main">
-            <a:r>
-              <a:t>约1分钟。18项测试涵盖城市/闭店/坐标过滤、缺失值、分块重叠、联系方式清理、文件校验、输入拒绝、地点去重和引用。还有浏览器手动验证，不能说这些等价于全部端到端自动测试。截图为实际运行中的 API。Sources: tests/; evidence/tests.txt; evidence/containers.txt; evidence/api-running.png.</a:t>
-            </a:r>
-          </a:p>
-        </p:txBody>
-      </p:sp>
-      <p:sp>
-        <p:nvSpPr>
-          <p:cNvPr id="4" name="Slide Number Placeholder 3"/>
-          <p:cNvSpPr>
-            <a:spLocks xmlns:a="http://schemas.openxmlformats.org/drawingml/2006/main" noGrp="1"/>
-          </p:cNvSpPr>
-          <p:nvPr>
-            <p:ph type="sldNum" idx="5"/>
-          </p:nvPr>
-        </p:nvSpPr>
-        <p:spPr/>
-        <p:txBody>
-          <a:bodyPr xmlns:a="http://schemas.openxmlformats.org/drawingml/2006/main"/>
-          <a:lstStyle xmlns:a="http://schemas.openxmlformats.org/drawingml/2006/main"/>
-          <a:p xmlns:a="http://schemas.openxmlformats.org/drawingml/2006/main"/>
-        </p:txBody>
-      </p:sp>
-    </p:spTree>
-  </p:cSld>
-  <p:clrMapOvr>
-    <a:masterClrMapping xmlns:a="http://schemas.openxmlformats.org/drawingml/2006/main"/>
-  </p:clrMapOvr>
-</p:notes>
+<ns0:notes xmlns:ns0="http://schemas.openxmlformats.org/presentationml/2006/main" xmlns:ns1="http://schemas.openxmlformats.org/drawingml/2006/main">
+  <ns0:cSld>
+    <ns0:spTree>
+      <ns0:nvGrpSpPr>
+        <ns0:cNvPr id="1" name=""/>
+        <ns0:cNvGrpSpPr/>
+        <ns0:nvPr/>
+      </ns0:nvGrpSpPr>
+      <ns0:grpSpPr>
+        <ns1:xfrm/>
+      </ns0:grpSpPr>
+      <ns0:sp>
+        <ns0:nvSpPr>
+          <ns0:cNvPr id="2" name="Slide Image Placeholder 1"/>
+          <ns0:cNvSpPr>
+            <ns1:spLocks noGrp="1"/>
+          </ns0:cNvSpPr>
+          <ns0:nvPr>
+            <ns0:ph type="sldImg" idx="0"/>
+          </ns0:nvPr>
+        </ns0:nvSpPr>
+        <ns0:spPr/>
+      </ns0:sp>
+      <ns0:sp>
+        <ns0:nvSpPr>
+          <ns0:cNvPr id="3" name="Notes Placeholder 2"/>
+          <ns0:cNvSpPr>
+            <ns1:spLocks noGrp="1"/>
+          </ns0:cNvSpPr>
+          <ns0:nvPr>
+            <ns0:ph type="body" idx="1"/>
+          </ns0:nvPr>
+        </ns0:nvSpPr>
+        <ns0:spPr/>
+        <ns0:txBody>
+          <ns1:bodyPr/>
+          <ns1:lstStyle/>
+          <ns1:p>
+            <ns1:r>
+              <ns1:t>About 1 minute. The earlier release passed 18 tests covering filters, missing values, chunks, contact removal, checksums, input rejection, deduplication and citations. These checks are not a complete end-to-end quality evaluation. The screenshot shows the running API. Sources: tests/; evidence/tests.txt; evidence/containers.txt; evidence/api-running.png. See docs/RAG_RESULTS.md for later verification.</ns1:t>
+            </ns1:r>
+          </ns1:p>
+        </ns0:txBody>
+      </ns0:sp>
+      <ns0:sp>
+        <ns0:nvSpPr>
+          <ns0:cNvPr id="4" name="Slide Number Placeholder 3"/>
+          <ns0:cNvSpPr>
+            <ns1:spLocks noGrp="1"/>
+          </ns0:cNvSpPr>
+          <ns0:nvPr>
+            <ns0:ph type="sldNum" idx="5"/>
+          </ns0:nvPr>
+        </ns0:nvSpPr>
+        <ns0:spPr/>
+        <ns0:txBody>
+          <ns1:bodyPr/>
+          <ns1:lstStyle/>
+          <ns1:p/>
+        </ns0:txBody>
+      </ns0:sp>
+    </ns0:spTree>
+  </ns0:cSld>
+  <ns0:clrMapOvr>
+    <ns1:masterClrMapping/>
+  </ns0:clrMapOvr>
+</ns0:notes>
 </file>
 
 <file path=ppt/slideLayouts/slideLayout1.xml><?xml version="1.0" encoding="utf-8"?>

</xml_diff>